<commit_message>
docs: reframe as local-first / on-device edge (cloud only for OCR) in README + deck
Architecture narrative now leads with the iQOO on-device edge — Qwen 3B via
llama.cpp runs the loop on the phone; Claude Opus vision is the sole cloud
touchpoint (OCR). Updated README architecture/run-it + deck title + arch slide.

Co-Authored-By: Claude Opus 4.8 (1M context) <noreply@anthropic.com>
</commit_message>
<xml_diff>
--- a/docs/Artha-Pitch.pptx
+++ b/docs/Artha-Pitch.pptx
@@ -3251,7 +3251,7 @@
         <p:spPr>
           <a:xfrm>
             <a:off x="822960" y="3840480"/>
-            <a:ext cx="10515600" cy="1097280"/>
+            <a:ext cx="10698480" cy="1280160"/>
           </a:xfrm>
           <a:prstGeom prst="rect">
             <a:avLst/>
@@ -3286,6 +3286,22 @@
                 <a:latin typeface="Arial"/>
               </a:rPr>
               <a:t>the phone is the only tool.</a:t>
+            </a:r>
+          </a:p>
+          <a:p>
+            <a:pPr algn="l">
+              <a:spcAft>
+                <a:spcPts val="400"/>
+              </a:spcAft>
+            </a:pPr>
+            <a:r>
+              <a:rPr sz="1700" b="1">
+                <a:solidFill>
+                  <a:srgbClr val="3CFFD0"/>
+                </a:solidFill>
+                <a:latin typeface="Arial"/>
+              </a:rPr>
+              <a:t>Local-first — runs on the iQOO's on-device edge; the cloud is touched only to OCR a photo.</a:t>
             </a:r>
           </a:p>
         </p:txBody>
@@ -5071,7 +5087,7 @@
         </p:nvSpPr>
         <p:spPr>
           <a:xfrm>
-            <a:off x="822960" y="640080"/>
+            <a:off x="822960" y="594360"/>
             <a:ext cx="10058400" cy="365760"/>
           </a:xfrm>
           <a:prstGeom prst="rect">
@@ -5097,7 +5113,7 @@
                 </a:solidFill>
                 <a:latin typeface="Consolas"/>
               </a:rPr>
-              <a:t>ARCHITECTURE · PHONE-FIRST</a:t>
+              <a:t>ARCHITECTURE · LOCAL-FIRST, ON-DEVICE EDGE</a:t>
             </a:r>
           </a:p>
         </p:txBody>
@@ -5110,8 +5126,8 @@
         </p:nvSpPr>
         <p:spPr>
           <a:xfrm>
-            <a:off x="822960" y="1097280"/>
-            <a:ext cx="3657600" cy="41148"/>
+            <a:off x="822960" y="1033271"/>
+            <a:ext cx="4572000" cy="41148"/>
           </a:xfrm>
           <a:prstGeom prst="rect">
             <a:avLst/>
@@ -5154,8 +5170,8 @@
         </p:nvSpPr>
         <p:spPr>
           <a:xfrm>
-            <a:off x="822960" y="1371600"/>
-            <a:ext cx="10515600" cy="822960"/>
+            <a:off x="822960" y="1261872"/>
+            <a:ext cx="10698480" cy="822960"/>
           </a:xfrm>
           <a:prstGeom prst="rect">
             <a:avLst/>
@@ -5180,7 +5196,7 @@
                 </a:solidFill>
                 <a:latin typeface="Arial Black"/>
               </a:rPr>
-              <a:t>Cloud AI when there's signal, on-device when there isn't — it never stops.</a:t>
+              <a:t>Runs on the iQOO's edge — nothing leaves the phone but an image for OCR.</a:t>
             </a:r>
           </a:p>
         </p:txBody>
@@ -5193,8 +5209,8 @@
         </p:nvSpPr>
         <p:spPr>
           <a:xfrm>
-            <a:off x="822960" y="2377440"/>
-            <a:ext cx="1828800" cy="777240"/>
+            <a:off x="822960" y="2240280"/>
+            <a:ext cx="2468880" cy="685800"/>
           </a:xfrm>
           <a:prstGeom prst="rect">
             <a:avLst/>
@@ -5213,13 +5229,13 @@
               </a:spcAft>
             </a:pPr>
             <a:r>
-              <a:rPr sz="1700" b="1">
+              <a:rPr sz="1350" b="1">
                 <a:solidFill>
                   <a:srgbClr val="3CFFD0"/>
                 </a:solidFill>
                 <a:latin typeface="Consolas"/>
               </a:rPr>
-              <a:t>LLM</a:t>
+              <a:t>ON-DEVICE LLM</a:t>
             </a:r>
           </a:p>
         </p:txBody>
@@ -5232,8 +5248,8 @@
         </p:nvSpPr>
         <p:spPr>
           <a:xfrm>
-            <a:off x="2743200" y="2377440"/>
-            <a:ext cx="8686800" cy="777240"/>
+            <a:off x="3383280" y="2240280"/>
+            <a:ext cx="8138160" cy="685800"/>
           </a:xfrm>
           <a:prstGeom prst="rect">
             <a:avLst/>
@@ -5252,13 +5268,13 @@
               </a:spcAft>
             </a:pPr>
             <a:r>
-              <a:rPr sz="1450" b="0">
+              <a:rPr sz="1350" b="0">
                 <a:solidFill>
                   <a:srgbClr val="FFFFFF"/>
                 </a:solidFill>
                 <a:latin typeface="Arial"/>
               </a:rPr>
-              <a:t>Cloud-first via OpenRouter — Claude Haiku 4.5 (agents/parsing) + Opus 4.8 (vision) — with an on-device llama.cpp (Qwen 3B) fallback.</a:t>
+              <a:t>Qwen 2.5 3B via llama.cpp parses entries, routes intents, and runs the insight loop on the iQOO — offline.</a:t>
             </a:r>
           </a:p>
         </p:txBody>
@@ -5271,8 +5287,8 @@
         </p:nvSpPr>
         <p:spPr>
           <a:xfrm>
-            <a:off x="822960" y="3218688"/>
-            <a:ext cx="1828800" cy="777240"/>
+            <a:off x="822960" y="2971800"/>
+            <a:ext cx="2468880" cy="685800"/>
           </a:xfrm>
           <a:prstGeom prst="rect">
             <a:avLst/>
@@ -5291,13 +5307,13 @@
               </a:spcAft>
             </a:pPr>
             <a:r>
-              <a:rPr sz="1700" b="1">
+              <a:rPr sz="1350" b="1">
                 <a:solidFill>
                   <a:srgbClr val="3CFFD0"/>
                 </a:solidFill>
                 <a:latin typeface="Consolas"/>
               </a:rPr>
-              <a:t>Voice</a:t>
+              <a:t>CLOUD = OCR ONLY</a:t>
             </a:r>
           </a:p>
         </p:txBody>
@@ -5310,8 +5326,8 @@
         </p:nvSpPr>
         <p:spPr>
           <a:xfrm>
-            <a:off x="2743200" y="3218688"/>
-            <a:ext cx="8686800" cy="777240"/>
+            <a:off x="3383280" y="2971800"/>
+            <a:ext cx="8138160" cy="685800"/>
           </a:xfrm>
           <a:prstGeom prst="rect">
             <a:avLst/>
@@ -5330,13 +5346,13 @@
               </a:spcAft>
             </a:pPr>
             <a:r>
-              <a:rPr sz="1450" b="0">
+              <a:rPr sz="1350" b="0">
                 <a:solidFill>
                   <a:srgbClr val="FFFFFF"/>
                 </a:solidFill>
                 <a:latin typeface="Arial"/>
               </a:rPr>
-              <a:t>On-device Hindi STT — fine-tuned whisper-hindi-small (whisper.cpp, JNI, arm64).</a:t>
+              <a:t>Claude Opus 4.8 vision reads Hindi handwriting — the one task that genuinely needs a frontier model. The sole cloud touchpoint.</a:t>
             </a:r>
           </a:p>
         </p:txBody>
@@ -5349,8 +5365,8 @@
         </p:nvSpPr>
         <p:spPr>
           <a:xfrm>
-            <a:off x="822960" y="4059936"/>
-            <a:ext cx="1828800" cy="777240"/>
+            <a:off x="822960" y="3703320"/>
+            <a:ext cx="2468880" cy="685800"/>
           </a:xfrm>
           <a:prstGeom prst="rect">
             <a:avLst/>
@@ -5369,13 +5385,13 @@
               </a:spcAft>
             </a:pPr>
             <a:r>
-              <a:rPr sz="1700" b="1">
+              <a:rPr sz="1350" b="1">
                 <a:solidFill>
                   <a:srgbClr val="3CFFD0"/>
                 </a:solidFill>
                 <a:latin typeface="Consolas"/>
               </a:rPr>
-              <a:t>Agent</a:t>
+              <a:t>VOICE</a:t>
             </a:r>
           </a:p>
         </p:txBody>
@@ -5388,8 +5404,8 @@
         </p:nvSpPr>
         <p:spPr>
           <a:xfrm>
-            <a:off x="2743200" y="4059936"/>
-            <a:ext cx="8686800" cy="777240"/>
+            <a:off x="3383280" y="3703320"/>
+            <a:ext cx="8138160" cy="685800"/>
           </a:xfrm>
           <a:prstGeom prst="rect">
             <a:avLst/>
@@ -5408,13 +5424,13 @@
               </a:spcAft>
             </a:pPr>
             <a:r>
-              <a:rPr sz="1450" b="0">
+              <a:rPr sz="1350" b="0">
                 <a:solidFill>
                   <a:srgbClr val="FFFFFF"/>
                 </a:solidFill>
                 <a:latin typeface="Arial"/>
               </a:rPr>
-              <a:t>Tool-calling over 8 read-only shop-data tools (P&amp;L, top-sellers, customer, day-trend, margins, low-stock, who-owes, inventory) + draft-action tools → confirm cards.</a:t>
+              <a:t>On-device Hindi STT — fine-tuned whisper-hindi-small (whisper.cpp, JNI, arm64).</a:t>
             </a:r>
           </a:p>
         </p:txBody>
@@ -5427,8 +5443,8 @@
         </p:nvSpPr>
         <p:spPr>
           <a:xfrm>
-            <a:off x="822960" y="4901184"/>
-            <a:ext cx="1828800" cy="777240"/>
+            <a:off x="822960" y="4434840"/>
+            <a:ext cx="2468880" cy="685800"/>
           </a:xfrm>
           <a:prstGeom prst="rect">
             <a:avLst/>
@@ -5447,13 +5463,13 @@
               </a:spcAft>
             </a:pPr>
             <a:r>
-              <a:rPr sz="1700" b="1">
+              <a:rPr sz="1350" b="1">
                 <a:solidFill>
                   <a:srgbClr val="3CFFD0"/>
                 </a:solidFill>
                 <a:latin typeface="Consolas"/>
               </a:rPr>
-              <a:t>Data</a:t>
+              <a:t>DATA</a:t>
             </a:r>
           </a:p>
         </p:txBody>
@@ -5466,8 +5482,8 @@
         </p:nvSpPr>
         <p:spPr>
           <a:xfrm>
-            <a:off x="2743200" y="4901184"/>
-            <a:ext cx="8686800" cy="777240"/>
+            <a:off x="3383280" y="4434840"/>
+            <a:ext cx="8138160" cy="685800"/>
           </a:xfrm>
           <a:prstGeom prst="rect">
             <a:avLst/>
@@ -5486,13 +5502,13 @@
               </a:spcAft>
             </a:pPr>
             <a:r>
-              <a:rPr sz="1450" b="0">
+              <a:rPr sz="1350" b="0">
                 <a:solidFill>
                   <a:srgbClr val="FFFFFF"/>
                 </a:solidFill>
                 <a:latin typeface="Arial"/>
               </a:rPr>
-              <a:t>Local Room/SQLite v3 — customers, price snapshots, reactive flows. Nothing critical leaves the phone.</a:t>
+              <a:t>Local Room/SQLite v3 — customers, price snapshots, reactive flows. The credit-grade record stays on the phone.</a:t>
             </a:r>
           </a:p>
         </p:txBody>
@@ -5505,8 +5521,8 @@
         </p:nvSpPr>
         <p:spPr>
           <a:xfrm>
-            <a:off x="822960" y="5742432"/>
-            <a:ext cx="1828800" cy="777240"/>
+            <a:off x="822960" y="5166360"/>
+            <a:ext cx="2468880" cy="685800"/>
           </a:xfrm>
           <a:prstGeom prst="rect">
             <a:avLst/>
@@ -5525,13 +5541,13 @@
               </a:spcAft>
             </a:pPr>
             <a:r>
-              <a:rPr sz="1700" b="1">
+              <a:rPr sz="1350" b="1">
                 <a:solidFill>
                   <a:srgbClr val="3CFFD0"/>
                 </a:solidFill>
                 <a:latin typeface="Consolas"/>
               </a:rPr>
-              <a:t>App</a:t>
+              <a:t>AGENT</a:t>
             </a:r>
           </a:p>
         </p:txBody>
@@ -5544,8 +5560,8 @@
         </p:nvSpPr>
         <p:spPr>
           <a:xfrm>
-            <a:off x="2743200" y="5742432"/>
-            <a:ext cx="8686800" cy="777240"/>
+            <a:off x="3383280" y="5166360"/>
+            <a:ext cx="8138160" cy="685800"/>
           </a:xfrm>
           <a:prstGeom prst="rect">
             <a:avLst/>
@@ -5564,7 +5580,85 @@
               </a:spcAft>
             </a:pPr>
             <a:r>
-              <a:rPr sz="1450" b="0">
+              <a:rPr sz="1350" b="0">
+                <a:solidFill>
+                  <a:srgbClr val="FFFFFF"/>
+                </a:solidFill>
+                <a:latin typeface="Arial"/>
+              </a:rPr>
+              <a:t>Tool-calling over 8 read-only shop-data tools + draft-action tools → confirm cards; answers with inline charts.</a:t>
+            </a:r>
+          </a:p>
+        </p:txBody>
+      </p:sp>
+      <p:sp>
+        <p:nvSpPr>
+          <p:cNvPr id="15" name="TextBox 14"/>
+          <p:cNvSpPr txBox="1"/>
+          <p:nvPr/>
+        </p:nvSpPr>
+        <p:spPr>
+          <a:xfrm>
+            <a:off x="822960" y="5897880"/>
+            <a:ext cx="2468880" cy="685800"/>
+          </a:xfrm>
+          <a:prstGeom prst="rect">
+            <a:avLst/>
+          </a:prstGeom>
+          <a:noFill/>
+        </p:spPr>
+        <p:txBody>
+          <a:bodyPr wrap="square" anchor="ctr">
+            <a:spAutoFit/>
+          </a:bodyPr>
+          <a:lstStyle/>
+          <a:p>
+            <a:pPr algn="l">
+              <a:spcAft>
+                <a:spcPts val="400"/>
+              </a:spcAft>
+            </a:pPr>
+            <a:r>
+              <a:rPr sz="1350" b="1">
+                <a:solidFill>
+                  <a:srgbClr val="3CFFD0"/>
+                </a:solidFill>
+                <a:latin typeface="Consolas"/>
+              </a:rPr>
+              <a:t>APP</a:t>
+            </a:r>
+          </a:p>
+        </p:txBody>
+      </p:sp>
+      <p:sp>
+        <p:nvSpPr>
+          <p:cNvPr id="16" name="TextBox 15"/>
+          <p:cNvSpPr txBox="1"/>
+          <p:nvPr/>
+        </p:nvSpPr>
+        <p:spPr>
+          <a:xfrm>
+            <a:off x="3383280" y="5897880"/>
+            <a:ext cx="8138160" cy="685800"/>
+          </a:xfrm>
+          <a:prstGeom prst="rect">
+            <a:avLst/>
+          </a:prstGeom>
+          <a:noFill/>
+        </p:spPr>
+        <p:txBody>
+          <a:bodyPr wrap="square" anchor="ctr">
+            <a:spAutoFit/>
+          </a:bodyPr>
+          <a:lstStyle/>
+          <a:p>
+            <a:pPr algn="l">
+              <a:spcAft>
+                <a:spcPts val="400"/>
+              </a:spcAft>
+            </a:pPr>
+            <a:r>
+              <a:rPr sz="1350" b="0">
                 <a:solidFill>
                   <a:srgbClr val="FFFFFF"/>
                 </a:solidFill>

</xml_diff>